<commit_message>
docs: update presentation with clickable links and QR
Co-authored-by: Cursor <cursoragent@cursor.com>
</commit_message>
<xml_diff>
--- a/slides/G05_STLF_DT_AdaBoost.pptx
+++ b/slides/G05_STLF_DT_AdaBoost.pptx
@@ -21,7 +21,7 @@
     <p:sldId id="272" r:id="rId15"/>
     <p:sldId id="273" r:id="rId16"/>
     <p:sldId id="274" r:id="rId17"/>
-    <p:sldId id="275" r:id="rId18"/>
+    <p:sldId id="278" r:id="rId18"/>
     <p:sldId id="277" r:id="rId19"/>
   </p:sldIdLst>
   <p:sldSz cx="12192000" cy="6858000"/>
@@ -13513,7 +13513,7 @@
         <p:spPr>
           <a:xfrm>
             <a:off x="384048" y="146304"/>
-            <a:ext cx="9144000" cy="492443"/>
+            <a:ext cx="9144000" cy="411480"/>
           </a:xfrm>
           <a:prstGeom prst="rect">
             <a:avLst/>
@@ -13526,7 +13526,7 @@
           </a:bodyPr>
           <a:lstStyle/>
           <a:p>
-            <a:pPr>
+            <a:pPr algn="l">
               <a:defRPr sz="2600" b="1">
                 <a:solidFill>
                   <a:srgbClr val="FFFFFF"/>
@@ -13534,18 +13534,8 @@
               </a:defRPr>
             </a:pPr>
             <a:r>
-              <a:rPr lang="tr-TR" dirty="0"/>
-              <a:t>Live </a:t>
-            </a:r>
-            <a:r>
-              <a:rPr lang="tr-TR" dirty="0" err="1"/>
-              <a:t>Forecast</a:t>
-            </a:r>
-            <a:r>
-              <a:rPr lang="tr-TR" dirty="0"/>
-              <a:t> — Web Demo</a:t>
-            </a:r>
-            <a:endParaRPr dirty="0"/>
+              <a:t>Live Forecast — Web Demo</a:t>
+            </a:r>
           </a:p>
         </p:txBody>
       </p:sp>
@@ -13558,7 +13548,7 @@
         <p:spPr>
           <a:xfrm>
             <a:off x="384048" y="530352"/>
-            <a:ext cx="8229600" cy="261610"/>
+            <a:ext cx="8229600" cy="256032"/>
           </a:xfrm>
           <a:prstGeom prst="rect">
             <a:avLst/>
@@ -13571,7 +13561,7 @@
           </a:bodyPr>
           <a:lstStyle/>
           <a:p>
-            <a:pPr>
+            <a:pPr algn="l">
               <a:defRPr sz="1100" b="0">
                 <a:solidFill>
                   <a:srgbClr val="38BDF8"/>
@@ -13579,14 +13569,8 @@
               </a:defRPr>
             </a:pPr>
             <a:r>
-              <a:rPr lang="en-US" dirty="0" err="1"/>
-              <a:t>FastAPI</a:t>
-            </a:r>
-            <a:r>
-              <a:rPr lang="en-US" dirty="0"/>
-              <a:t> · ML in the browser</a:t>
-            </a:r>
-            <a:endParaRPr dirty="0"/>
+              <a:t>FastAPI · ML in the browser</a:t>
+            </a:r>
           </a:p>
         </p:txBody>
       </p:sp>
@@ -13704,59 +13688,9 @@
           </a:p>
         </p:txBody>
       </p:sp>
-      <p:sp>
-        <p:nvSpPr>
-          <p:cNvPr id="18" name="Rounded Rectangle 17"/>
-          <p:cNvSpPr/>
-          <p:nvPr/>
-        </p:nvSpPr>
-        <p:spPr>
-          <a:xfrm>
-            <a:off x="4730035" y="5067848"/>
-            <a:ext cx="2932406" cy="1259800"/>
-          </a:xfrm>
-          <a:prstGeom prst="roundRect">
-            <a:avLst/>
-          </a:prstGeom>
-          <a:solidFill>
-            <a:srgbClr val="00C9A7"/>
-          </a:solidFill>
-          <a:ln>
-            <a:noFill/>
-          </a:ln>
-        </p:spPr>
-        <p:style>
-          <a:lnRef idx="1">
-            <a:schemeClr val="accent1"/>
-          </a:lnRef>
-          <a:fillRef idx="3">
-            <a:schemeClr val="accent1"/>
-          </a:fillRef>
-          <a:effectRef idx="2">
-            <a:schemeClr val="accent1"/>
-          </a:effectRef>
-          <a:fontRef idx="minor">
-            <a:schemeClr val="lt1"/>
-          </a:fontRef>
-        </p:style>
-        <p:txBody>
-          <a:bodyPr rtlCol="0" anchor="ctr"/>
-          <a:lstStyle/>
-          <a:p>
-            <a:pPr algn="ctr"/>
-            <a:endParaRPr dirty="0"/>
-          </a:p>
-        </p:txBody>
-      </p:sp>
       <p:pic>
         <p:nvPicPr>
-          <p:cNvPr id="21" name="Resim 20">
-            <a:extLst>
-              <a:ext uri="{FF2B5EF4-FFF2-40B4-BE49-F238E27FC236}">
-                <a16:creationId xmlns:a16="http://schemas.microsoft.com/office/drawing/2014/main" id="{DAFECFE0-161D-409A-B8E6-27CFCE79BFB7}"/>
-              </a:ext>
-            </a:extLst>
-          </p:cNvPr>
+          <p:cNvPr id="9" name="Picture 8" descr="qr_live_demo.png"/>
           <p:cNvPicPr>
             <a:picLocks noChangeAspect="1"/>
           </p:cNvPicPr>
@@ -13770,8 +13704,8 @@
         </p:blipFill>
         <p:spPr>
           <a:xfrm>
-            <a:off x="4138186" y="1097280"/>
-            <a:ext cx="3915321" cy="3924848"/>
+            <a:off x="4090635" y="941832"/>
+            <a:ext cx="4010424" cy="4010424"/>
           </a:xfrm>
           <a:prstGeom prst="rect">
             <a:avLst/>
@@ -13780,20 +13714,58 @@
       </p:pic>
       <p:sp>
         <p:nvSpPr>
-          <p:cNvPr id="22" name="Metin kutusu 21">
-            <a:extLst>
-              <a:ext uri="{FF2B5EF4-FFF2-40B4-BE49-F238E27FC236}">
-                <a16:creationId xmlns:a16="http://schemas.microsoft.com/office/drawing/2014/main" id="{1FE1C4E4-D32D-E090-4FBF-B37B776B524D}"/>
-              </a:ext>
-            </a:extLst>
-          </p:cNvPr>
+          <p:cNvPr id="11" name="Rounded Rectangle 10"/>
+          <p:cNvSpPr/>
+          <p:nvPr/>
+        </p:nvSpPr>
+        <p:spPr>
+          <a:xfrm>
+            <a:off x="603504" y="4754290"/>
+            <a:ext cx="5074920" cy="658368"/>
+          </a:xfrm>
+          <a:prstGeom prst="roundRect">
+            <a:avLst/>
+          </a:prstGeom>
+          <a:solidFill>
+            <a:srgbClr val="00C9A7"/>
+          </a:solidFill>
+          <a:ln>
+            <a:noFill/>
+          </a:ln>
+        </p:spPr>
+        <p:style>
+          <a:lnRef idx="1">
+            <a:schemeClr val="accent1"/>
+          </a:lnRef>
+          <a:fillRef idx="3">
+            <a:schemeClr val="accent1"/>
+          </a:fillRef>
+          <a:effectRef idx="2">
+            <a:schemeClr val="accent1"/>
+          </a:effectRef>
+          <a:fontRef idx="minor">
+            <a:schemeClr val="lt1"/>
+          </a:fontRef>
+        </p:style>
+        <p:txBody>
+          <a:bodyPr rtlCol="0" anchor="ctr"/>
+          <a:lstStyle/>
+          <a:p>
+            <a:pPr algn="ctr"/>
+            <a:endParaRPr/>
+          </a:p>
+        </p:txBody>
+      </p:sp>
+      <p:sp>
+        <p:nvSpPr>
+          <p:cNvPr id="12" name="TextBox 11"/>
           <p:cNvSpPr txBox="1"/>
           <p:nvPr/>
         </p:nvSpPr>
         <p:spPr>
           <a:xfrm>
-            <a:off x="4730035" y="5189916"/>
-            <a:ext cx="2932406" cy="1015663"/>
+            <a:off x="603504" y="4911149"/>
+            <a:ext cx="4855464" cy="307777"/>
           </a:xfrm>
           <a:prstGeom prst="rect">
             <a:avLst/>
@@ -13801,17 +13773,106 @@
           <a:noFill/>
         </p:spPr>
         <p:txBody>
-          <a:bodyPr wrap="square" rtlCol="0">
+          <a:bodyPr wrap="square">
             <a:spAutoFit/>
           </a:bodyPr>
           <a:lstStyle/>
           <a:p>
             <a:pPr algn="ctr"/>
             <a:r>
-              <a:rPr lang="en-US" sz="2000" b="1" i="1" dirty="0"/>
+              <a:rPr sz="1400" b="1" i="1" u="sng" dirty="0">
+                <a:hlinkClick r:id="rId3">
+                  <a:extLst>
+                    <a:ext uri="{A12FA001-AC4F-418D-AE19-62706E023703}">
+                      <ahyp:hlinkClr xmlns:ahyp="http://schemas.microsoft.com/office/drawing/2018/hyperlinkcolor" val="tx"/>
+                    </a:ext>
+                  </a:extLst>
+                </a:hlinkClick>
+              </a:rPr>
               <a:t>You can scan the QR code to experience the live site for yourself</a:t>
             </a:r>
-            <a:endParaRPr lang="tr-TR" sz="2000" b="1" i="1" dirty="0"/>
+          </a:p>
+        </p:txBody>
+      </p:sp>
+      <p:sp>
+        <p:nvSpPr>
+          <p:cNvPr id="13" name="Rounded Rectangle 12"/>
+          <p:cNvSpPr/>
+          <p:nvPr/>
+        </p:nvSpPr>
+        <p:spPr>
+          <a:xfrm>
+            <a:off x="6512193" y="4751242"/>
+            <a:ext cx="5074920" cy="658368"/>
+          </a:xfrm>
+          <a:prstGeom prst="roundRect">
+            <a:avLst/>
+          </a:prstGeom>
+          <a:solidFill>
+            <a:srgbClr val="00C9A7"/>
+          </a:solidFill>
+          <a:ln>
+            <a:noFill/>
+          </a:ln>
+        </p:spPr>
+        <p:style>
+          <a:lnRef idx="1">
+            <a:schemeClr val="accent1"/>
+          </a:lnRef>
+          <a:fillRef idx="3">
+            <a:schemeClr val="accent1"/>
+          </a:fillRef>
+          <a:effectRef idx="2">
+            <a:schemeClr val="accent1"/>
+          </a:effectRef>
+          <a:fontRef idx="minor">
+            <a:schemeClr val="lt1"/>
+          </a:fontRef>
+        </p:style>
+        <p:txBody>
+          <a:bodyPr rtlCol="0" anchor="ctr"/>
+          <a:lstStyle/>
+          <a:p>
+            <a:pPr algn="ctr"/>
+            <a:endParaRPr/>
+          </a:p>
+        </p:txBody>
+      </p:sp>
+      <p:sp>
+        <p:nvSpPr>
+          <p:cNvPr id="14" name="TextBox 13"/>
+          <p:cNvSpPr txBox="1"/>
+          <p:nvPr/>
+        </p:nvSpPr>
+        <p:spPr>
+          <a:xfrm>
+            <a:off x="6518367" y="4911149"/>
+            <a:ext cx="4855464" cy="338554"/>
+          </a:xfrm>
+          <a:prstGeom prst="rect">
+            <a:avLst/>
+          </a:prstGeom>
+          <a:noFill/>
+        </p:spPr>
+        <p:txBody>
+          <a:bodyPr wrap="square">
+            <a:spAutoFit/>
+          </a:bodyPr>
+          <a:lstStyle/>
+          <a:p>
+            <a:pPr algn="ctr"/>
+            <a:r>
+              <a:rPr sz="1600" b="1" i="0" u="sng" dirty="0">
+                <a:hlinkClick r:id="rId4">
+                  <a:extLst>
+                    <a:ext uri="{A12FA001-AC4F-418D-AE19-62706E023703}">
+                      <ahyp:hlinkClr xmlns:ahyp="http://schemas.microsoft.com/office/drawing/2018/hyperlinkcolor" val="tx"/>
+                    </a:ext>
+                  </a:extLst>
+                </a:hlinkClick>
+              </a:rPr>
+              <a:t>https://github.com/ahmetbtopcu/mee344-g05-stlf</a:t>
+            </a:r>
           </a:p>
         </p:txBody>
       </p:sp>

</xml_diff>